<commit_message>
auto: prompt checkpoint @ 2026-05-25T11:50:26+08:00
</commit_message>
<xml_diff>
--- a/docs/RDTII_AutoExtract.pptx
+++ b/docs/RDTII_AutoExtract.pptx
@@ -511,13 +511,7 @@
           <a:lstStyle/>
           <a:p>
             <a:r>
-              <a:t>Good day, and thank you for the opportunity to present. This presentation introduces RDTII AutoExtract, an open-source, model-agnostic artificial intelligence pipeline that we have developed for the Global Hackathon on AI for Digital Trade Regulatory Analysis, jointly organised by UN ESCAP and KMITL.</a:t>
-            </a:r>
-          </a:p>
-          <a:p/>
-          <a:p>
-            <a:r>
-              <a:t>The central objective of the project is to automate approximately eighty percent of the RDTII regulatory workflow — specifically the discovery and description stages — while deliberately preserving a transparent human review step for the remaining twenty percent. Our scope addresses the two mandatory pillars: Pillar 6, Cross-Border Data Flows, and Pillar 7, Domestic Data Protection, at article-level granularity. The entire system is released under the Apache 2.0 licence to ensure it is freely reusable by the policy community. Over the next slides I will outline the problem, our objectives, the system architecture, and the measurable outcomes we are targeting.</a:t>
+              <a:t>[0:00–0:15] We are Team Arkova. We built RDTII AutoExtract — an open-source, model-agnostic pipeline that automates roughly eighty percent of the RDTII workflow for Pillars 6 and 7 across Asia-Pacific jurisdictions.</a:t>
             </a:r>
           </a:p>
         </p:txBody>
@@ -587,13 +581,7 @@
           <a:lstStyle/>
           <a:p>
             <a:r>
-              <a:t>In closing, let me restate why we believe this project matters. The primary contribution is not a novel model architecture; it is a complete, deployable, end-to-end pipeline that is purpose-built for the RDTII legal extraction task and that does not currently exist in open-source form.</a:t>
-            </a:r>
-          </a:p>
-          <a:p/>
-          <a:p>
-            <a:r>
-              <a:t>To summarise the four points on screen: first, the system automates approximately eighty percent of the discover-to-describe workflow for Pillars 6 and 7. Second, it is model-agnostic by design, which makes it open-weight capable, fully self-hostable, and released under Apache 2.0. Third, it performs genuine article-level extraction, capturing all six mandatory fields with traceable citations and confidence scores. And fourth, it keeps a human firmly in the loop through a non-technical review interface, while contributing a navigable concept graph that turns isolated provisions into connected knowledge. Thank you very much for your attention; I would be glad to take any questions.</a:t>
+              <a:t>[3:55–4:00] To close: not a new model — a complete, deployable, open-source RDTII pipeline that does not yet exist. Auditable, multilingual, and built for the people who do the work. Thank you.</a:t>
             </a:r>
           </a:p>
         </p:txBody>
@@ -663,13 +651,7 @@
           <a:lstStyle/>
           <a:p>
             <a:r>
-              <a:t>Allow me to begin with the problem we set out to solve. At present, the RDTII workflow is almost entirely manual. ESCAP researchers must search government portals by hand, retrieve regulatory documents, read through dense legal text, and then extract structured data — and they must do this at article-level granularity, not merely at the document level.</a:t>
-            </a:r>
-          </a:p>
-          <a:p/>
-          <a:p>
-            <a:r>
-              <a:t>This work spans numerous Asia-Pacific jurisdictions and several languages, which makes it time-intensive and very difficult to scale. Throughput is bounded by researcher availability and by the languages each researcher can read. Furthermore, any regulatory document that is not already in the ESCAP database is easily overlooked. The figures on the right summarise the burden: the effort is essentially one hundred percent manual, it must cover many jurisdictions and languages, and it demands per-article precision. This is precisely the bottleneck our pipeline is designed to relieve.</a:t>
+              <a:t>[0:15–0:40] The problem we tackle is simple: today the RDTII workflow is almost entirely manual. ESCAP researchers search government portals, retrieve PDFs, read dense legal text, and extract structured fields — article by article, across many jurisdictions and languages. It does not scale, and existing literature targets the EU AI Act and GDPR, not RDTII.</a:t>
             </a:r>
           </a:p>
         </p:txBody>
@@ -739,13 +721,7 @@
           <a:lstStyle/>
           <a:p>
             <a:r>
-              <a:t>Our objectives follow directly from that problem. First, we aim to automate document discovery so that the system can locate relevant regulations even when they lie outside the existing ESCAP database. Second, we target genuine article-level extraction, capturing all six mandatory fields — title, last update, URL, scope, provisions, and impact — for every article.</a:t>
-            </a:r>
-          </a:p>
-          <a:p/>
-          <a:p>
-            <a:r>
-              <a:t>Third, every extracted provision must be mapped to the correct Pillar 6 or Pillar 7 sub-indicator, and each mapping must carry a verifiable citation back to the source. Fourth, the tool must be self-hostable and fully open-source, with no dependency on proprietary infrastructure in production. Fifth — and this is central to our design philosophy — every AI component must be model-agnostic and swappable to open-weight models through configuration alone. Finally, we commit to a human-first review experience: a non-technical interface in which any mapping can be verified, edited, or rejected within seconds.</a:t>
+              <a:t>[0:40–1:00] Our six objectives follow directly. Automate discovery beyond the ESCAP database. Extract all six mandatory fields at article-level. Map every provision to Pillar 6 or 7 sub-indicators with verifiable citations. Ship a self-hostable open tool. Keep every AI component swappable. And provide a human-first review surface.</a:t>
             </a:r>
           </a:p>
         </p:txBody>
@@ -815,13 +791,7 @@
           <a:lstStyle/>
           <a:p>
             <a:r>
-              <a:t>This slide explains the single most important architectural decision in the project: the system is model-agnostic by design. We build on a ports and adapters — also called hexagonal — architecture. The core domain, which contains the business logic of the RDTII workflow, depends only on interfaces, which we call ports. It never references a concrete model directly.</a:t>
-            </a:r>
-          </a:p>
-          <a:p/>
-          <a:p>
-            <a:r>
-              <a:t>Every artificial intelligence component — the large language model, the OCR engine, the captioner, the embedding model, and the graph library — is implemented as an adapter behind one of those ports. As a result, each model is a swappable suggestion rather than a hardcoded commitment. We can run a paid commercial API during development for convenience, and then, for production, resolve every call to an open-weight model such as Llama 3.1 served through Ollama — changing only configuration, with no edits to the domain code. This is not merely an engineering preference: the hackathon rubric explicitly rewards swappability, awarding twenty points in Stage 1 and a further twenty points in Stage 3. The diagram on the right shows the core surrounded by interchangeable adapters.</a:t>
+              <a:t>[1:00–1:25] To make swappability real, we build on ports and adapters. The core domain depends only on interfaces — never on a concrete model. Every AI component — LLM, OCR, captioner, embeddings, vector store, graph library — is an adapter behind a port, changed via configuration. No vendor lock-in, no production proprietary dependency.</a:t>
             </a:r>
           </a:p>
         </p:txBody>
@@ -891,13 +861,7 @@
           <a:lstStyle/>
           <a:p>
             <a:r>
-              <a:t>Here is the pipeline as a whole. It runs in five stages. The first four stages cover the discover-to-describe arc that the hackathon requires, and the fifth stage adds our distinctive contribution.</a:t>
-            </a:r>
-          </a:p>
-          <a:p/>
-          <a:p>
-            <a:r>
-              <a:t>In Stage 1, Discovery and Retrieval, a crawler targets national legislation portals, official gazettes, and ministry websites, recording full provenance for every document. In Stage 2, OCR and Captioning, we convert any document format into clean, machine-readable text at below five percent character error rate; importantly, a SigLIP-style caption is produced for each section and becomes the basis for tagging, so the tags are not held hostage to OCR noise. In Stage 3, Tagging and Extraction, each article is multi-label tagged, and a retrieval-augmented generation step extracts all six mandatory fields together with citations and a confidence score. Stage 4 is the Human Review interface, where a non-technical researcher can accept, reject, or edit any mapping in seconds, with each record linked back to its source. Finally, Stage 5 connects the tagged provisions into a weighted, pruned, navigable concept graph — which I will describe in more detail shortly.</a:t>
+              <a:t>[1:25–2:35] The pipeline runs in five stages. Stages one and two handle automated discovery of legal documents. A crawler — Playwright with anti-bot handling and archive fallback — locates regulations on national portals, gazettes, and ministry sites, recording full provenance per document. Then OCR converts every format to clean text at under five percent character error rate, and a vision-language captioner produces a short descriptor of each section. That caption becomes the basis for every downstream tag, so we are not hostage to OCR noise on scanned or non-English documents. Stage three handles mapping. We tag each section multi-label against indicator labels, then a RAG-based LLM call extracts the six mandatory fields with strict JSON schema and a source citation. Stage four is human verification — a non-technical reviewer console where any mapping is accepted, rejected, or edited in seconds, with a direct link back to the source span.</a:t>
             </a:r>
           </a:p>
         </p:txBody>
@@ -967,13 +931,7 @@
           <a:lstStyle/>
           <a:p>
             <a:r>
-              <a:t>Stage 5 is what we consider the core architectural contribution of the project, because it goes beyond extraction and turns isolated records into knowledge. After tagging, each article becomes a node. We then draw weighted edges between nodes based on two signals: the overlap of their tags, weighted by inverse document frequency, and the cosine similarity of their embeddings.</a:t>
-            </a:r>
-          </a:p>
-          <a:p/>
-          <a:p>
-            <a:r>
-              <a:t>To keep the graph meaningful and reproducible, we apply pseudo-deterministic threshold pruning: every edge below a calibrated threshold, theta, is removed, and because we fix the random seeds and theta, the same inputs always produce the same graph. We then run community detection using NetworkX and the Louvain method — deliberately chosen because it is BSD-licensed and therefore compatible with our Apache repository. On top of this we apply Formal Concept Analysis to build a generality hierarchy, where provisions with more tags are more specific, and weighted PageRank to rank entry points. The outcome is a navigable map: the reader starts from broad entry-point categories and drills down into ranked, specific sub-topics, with related provisions cross-linked automatically.</a:t>
+              <a:t>[2:35–3:15] Stage five is our core contribution. From the tagged nodes, we derive two artifacts in parallel. The concept graph is subtractive — we start from the complete pairwise graph and drop edges below a calibrated threshold, leaving only topical borders. Then Louvain communities and weighted PageRank score importance within the surviving web. Independently, Formal Concept Analysis on the node-by-tag matrix produces a generality tree: more tags imply fewer matching sections, so depth equals specificity. Together they give us entry-point categories opening into ranked subcategories — navigable cross-jurisdiction evidence.</a:t>
             </a:r>
           </a:p>
         </p:txBody>
@@ -1043,13 +1001,7 @@
           <a:lstStyle/>
           <a:p>
             <a:r>
-              <a:t>This table sets out the technology stack, but the way to read it is important. Each row is a layer that sits behind a port — an interface. The middle column lists the adapter we suggest for development, and the right column lists the open-weight target we resolve to in production. The point is that these are reference suggestions, not hard commitments; any of them can be replaced through configuration.</a:t>
-            </a:r>
-          </a:p>
-          <a:p/>
-          <a:p>
-            <a:r>
-              <a:t>For the language model we may use Claude or GPT in development and Llama 3.1 in production. For captioning we use Qwen2-VL or ColQwen2, both Apache-licensed, with an OCR-text fallback. Embeddings use the multilingual BGE-M3 model. OCR is handled by Tesseract 5 with OpenCV, falling back to PaddleOCR for Southeast Asian scripts. The vector store is pgvector or Chroma, both self-hostable. The graph layer uses NetworkX and an MIT-licensed Formal Concept Analysis library. Backend is FastAPI, frontend is Next.js, and the whole system ships with Docker Compose. Critically, every component is Apache-2.0-compatible, which is a licensing requirement of the competition, and each reused component will be disclosed in the Technical Memo with its licence verified.</a:t>
+              <a:t>[3:15–3:35] Every model named here is a starting suggestion, not a commitment. Development uses Claude or GPT; production resolves to open-weight Llama 3.1 via Ollama with a single config change. All reused components are Apache-2.0 compatible, audited for license discipline.</a:t>
             </a:r>
           </a:p>
         </p:txBody>
@@ -1119,13 +1071,7 @@
           <a:lstStyle/>
           <a:p>
             <a:r>
-              <a:t>Beyond the design, the project must be credible in practice, so this slide addresses coverage, cost, and sustainability. On coverage, in Round 1 the tool will be evaluated against five to ten documents from three provided countries, including at least one non-English jurisdiction handled by our translation pipeline. The architecture is designed to scale to the ten assigned countries at the finale without any retraining.</a:t>
-            </a:r>
-          </a:p>
-          <a:p/>
-          <a:p>
-            <a:r>
-              <a:t>On cost, the figures are deliberately conservative. In the open-weight configuration, running Llama 3.1 8B locally, the API fee for a fifty-page document is effectively zero; the only cost is cloud GPU compute, approximately five to ten US cents per document at batch rates. If a commercial API is used instead, the cost is roughly ten to twenty-five cents per document. On sustainability, the entire pipeline is self-hostable through Docker on commodity hardware, with no proprietary dependency in production, and its modular design means the OCR engine, the language model, and the vector database can each be upgraded independently over time. Exact benchmarks will be reported in the Technical Memo after empirical testing.</a:t>
+              <a:t>[3:35–3:50] On viability — open-weight self-hosted cost is roughly five to ten cents per fifty-page document, API at ten to twenty-five cents. We are finale-ready for ten countries with no retraining. Everything ships via docker-compose on commodity hardware.</a:t>
             </a:r>
           </a:p>
         </p:txBody>
@@ -1195,13 +1141,7 @@
           <a:lstStyle/>
           <a:p>
             <a:r>
-              <a:t>This slide lays out the timeline through to the award ceremony. The immediate milestone is the application submission on the twenty-fifth of May 2026, which comprises our CVs, the concept video, the Technical Memo, and the signed declaration. The shortlist is announced at the end of May, followed by ESCAP and KMITL training workshops in early June.</a:t>
-            </a:r>
-          </a:p>
-          <a:p/>
-          <a:p>
-            <a:r>
-              <a:t>The first major technical checkpoint is the Round 1 submission on the twentieth of July, where the tool is evaluated on three provided countries, followed by the hybrid pitch at the end of that month. The final submission is due on the thirtieth of September, and the award ceremony takes place in Bangkok on the fifteenth of October. Our development plan is sequenced so that a working three-country demonstration is ready well ahead of Round 1, leaving the remaining time for hardening, additional country coverage, and the empirical benchmarking we will report in the memo.</a:t>
+              <a:t>[3:50–3:55] The path to October runs from the May application through training workshops, Round 1, the hybrid pitch, and the Bangkok finale.</a:t>
             </a:r>
           </a:p>
         </p:txBody>
@@ -4506,14 +4446,6 @@
           </a:bodyPr>
           <a:lstStyle/>
           <a:p>
-            <a:pPr algn="l">
-              <a:spcBef>
-                <a:spcPts val="0"/>
-              </a:spcBef>
-              <a:spcAft>
-                <a:spcPts val="0"/>
-              </a:spcAft>
-            </a:pPr>
             <a:r>
               <a:rPr sz="1300" b="1" i="0">
                 <a:solidFill>
@@ -4521,7 +4453,7 @@
                 </a:solidFill>
                 <a:latin typeface="Calibri"/>
               </a:rPr>
-              <a:t>Licensed under Apache 2.0</a:t>
+              <a:t>Team Arkova   ·   Licensed under Apache 2.0</a:t>
             </a:r>
           </a:p>
         </p:txBody>
@@ -4905,14 +4837,6 @@
           </a:bodyPr>
           <a:lstStyle/>
           <a:p>
-            <a:pPr algn="l">
-              <a:spcBef>
-                <a:spcPts val="0"/>
-              </a:spcBef>
-              <a:spcAft>
-                <a:spcPts val="0"/>
-              </a:spcAft>
-            </a:pPr>
             <a:r>
               <a:rPr sz="1300" b="0" i="0">
                 <a:solidFill>
@@ -4920,7 +4844,7 @@
                 </a:solidFill>
                 <a:latin typeface="Calibri"/>
               </a:rPr>
-              <a:t>Thank you.   ·   Repository to be published under Apache 2.0   ·   escap-digitaltrade-hackathon@un.org</a:t>
+              <a:t>Team Arkova   ·   Repository to be published under Apache 2.0   ·   escap-digitaltrade-hackathon@un.org</a:t>
             </a:r>
           </a:p>
         </p:txBody>
@@ -9946,11 +9870,6 @@
           </a:bodyPr>
           <a:lstStyle/>
           <a:p>
-            <a:pPr algn="l">
-              <a:spcAft>
-                <a:spcPts val="1200"/>
-              </a:spcAft>
-            </a:pPr>
             <a:r>
               <a:rPr sz="1500" b="1">
                 <a:solidFill>
@@ -9958,24 +9877,10 @@
                 </a:solidFill>
                 <a:latin typeface="Calibri"/>
               </a:rPr>
-              <a:t>—  </a:t>
-            </a:r>
-            <a:r>
-              <a:rPr sz="1500" b="0">
-                <a:solidFill>
-                  <a:srgbClr val="334455"/>
-                </a:solidFill>
-                <a:latin typeface="Calibri"/>
-              </a:rPr>
-              <a:t>Edges weight tag overlap (IDF-weighted) and embedding cosine similarity between provisions.</a:t>
-            </a:r>
-          </a:p>
-          <a:p>
-            <a:pPr algn="l">
-              <a:spcAft>
-                <a:spcPts val="1200"/>
-              </a:spcAft>
-            </a:pPr>
+              <a:t>—  One shared seed: tagged nodes from Stage 3. Stage 5 derives two artifacts in parallel.</a:t>
+            </a:r>
+          </a:p>
+          <a:p>
             <a:r>
               <a:rPr sz="1500" b="1">
                 <a:solidFill>
@@ -9983,24 +9888,10 @@
                 </a:solidFill>
                 <a:latin typeface="Calibri"/>
               </a:rPr>
-              <a:t>—  </a:t>
-            </a:r>
-            <a:r>
-              <a:rPr sz="1500" b="0">
-                <a:solidFill>
-                  <a:srgbClr val="334455"/>
-                </a:solidFill>
-                <a:latin typeface="Calibri"/>
-              </a:rPr>
-              <a:t>Pseudo-deterministic threshold pruning: edges below a calibrated θ are removed; results reproduce given fixed seeds and θ.</a:t>
-            </a:r>
-          </a:p>
-          <a:p>
-            <a:pPr algn="l">
-              <a:spcAft>
-                <a:spcPts val="1200"/>
-              </a:spcAft>
-            </a:pPr>
+              <a:t>—  Concept graph (subtractive): start from the complete pairwise graph, then drop edges where w = α·IDF-Jaccard(tags) + (1−α)·cosine(emb) falls below a calibrated θ. Louvain communities + weighted PageRank score influence.</a:t>
+            </a:r>
+          </a:p>
+          <a:p>
             <a:r>
               <a:rPr sz="1500" b="1">
                 <a:solidFill>
@@ -10008,66 +9899,18 @@
                 </a:solidFill>
                 <a:latin typeface="Calibri"/>
               </a:rPr>
-              <a:t>—  </a:t>
-            </a:r>
-            <a:r>
-              <a:rPr sz="1500" b="0">
-                <a:solidFill>
-                  <a:srgbClr val="334455"/>
-                </a:solidFill>
-                <a:latin typeface="Calibri"/>
-              </a:rPr>
-              <a:t>Community detection (NetworkX / Louvain — BSD) produces Obsidian-style topical groupings.</a:t>
-            </a:r>
-          </a:p>
-          <a:p>
-            <a:pPr algn="l">
-              <a:spcAft>
-                <a:spcPts val="1200"/>
-              </a:spcAft>
-            </a:pPr>
+              <a:t>—  Generality tree (algebraic): Formal Concept Analysis on the node × tag matrix — independent of graph edges. Intent = tags, extent = sections; more tags ⇒ deeper, more specific. Together: entry-point category → PageRank-ranked subcategories.</a:t>
+            </a:r>
+          </a:p>
+          <a:p>
             <a:r>
               <a:rPr sz="1500" b="1">
                 <a:solidFill>
-                  <a:srgbClr val="2E8B6F"/>
-                </a:solidFill>
-                <a:latin typeface="Calibri"/>
-              </a:rPr>
-              <a:t>—  </a:t>
-            </a:r>
-            <a:r>
-              <a:rPr sz="1500" b="0">
-                <a:solidFill>
-                  <a:srgbClr val="334455"/>
-                </a:solidFill>
-                <a:latin typeface="Calibri"/>
-              </a:rPr>
-              <a:t>Formal Concept Analysis builds a generality hierarchy; weighted PageRank ranks entry points and orders within levels.</a:t>
-            </a:r>
-          </a:p>
-          <a:p>
-            <a:pPr algn="l">
-              <a:spcAft>
-                <a:spcPts val="0"/>
-              </a:spcAft>
-            </a:pPr>
-            <a:r>
-              <a:rPr sz="1500" b="1">
-                <a:solidFill>
-                  <a:srgbClr val="2E8B6F"/>
-                </a:solidFill>
-                <a:latin typeface="Calibri"/>
-              </a:rPr>
-              <a:t>—  </a:t>
-            </a:r>
-            <a:r>
-              <a:rPr sz="1500" b="1">
-                <a:solidFill>
-                  <a:srgbClr val="334455"/>
-                </a:solidFill>
-                <a:latin typeface="Calibri"/>
-              </a:rPr>
-              <a:t>Result: broad entry-point categories → ranked specific sub-topics — a navigable map of related provisions.</a:t>
+                  <a:srgbClr val="1F6FB2"/>
+                </a:solidFill>
+                <a:latin typeface="Calibri"/>
+              </a:rPr>
+              <a:t>—  Pseudo-deterministic: fixed seeds + θ ⇒ reproducible. Every edge stores its basis (shared tags, cosine) — no black-box connections.</a:t>
             </a:r>
           </a:p>
         </p:txBody>

</xml_diff>

<commit_message>
auto: prompt checkpoint @ 2026-05-25T11:57:25+08:00
</commit_message>
<xml_diff>
--- a/docs/RDTII_AutoExtract.pptx
+++ b/docs/RDTII_AutoExtract.pptx
@@ -511,7 +511,13 @@
           <a:lstStyle/>
           <a:p>
             <a:r>
-              <a:t>[0:00–0:15] We are Team Arkova. We built RDTII AutoExtract — an open-source, model-agnostic pipeline that automates roughly eighty percent of the RDTII workflow for Pillars 6 and 7 across Asia-Pacific jurisdictions.</a:t>
+              <a:t>Good day, and thank you for the opportunity to present. This presentation introduces Zetarix, an open-source, model-agnostic artificial intelligence pipeline that we have developed for the Global Hackathon on AI for Digital Trade Regulatory Analysis, jointly organised by UN ESCAP and KMITL.</a:t>
+            </a:r>
+          </a:p>
+          <a:p/>
+          <a:p>
+            <a:r>
+              <a:t>The central objective of the project is to automate approximately eighty percent of the RDTII regulatory workflow — specifically the discovery and description stages — while deliberately preserving a transparent human review step for the remaining twenty percent. Our scope addresses the two mandatory pillars: Pillar 6, Cross-Border Data Flows, and Pillar 7, Domestic Data Protection, at article-level granularity. The entire system is released under the Apache 2.0 licence to ensure it is freely reusable by the policy community. Over the next slides I will outline the problem, our objectives, the system architecture, and the measurable outcomes we are targeting.</a:t>
             </a:r>
           </a:p>
         </p:txBody>
@@ -581,7 +587,13 @@
           <a:lstStyle/>
           <a:p>
             <a:r>
-              <a:t>[3:55–4:00] To close: not a new model — a complete, deployable, open-source RDTII pipeline that does not yet exist. Auditable, multilingual, and built for the people who do the work. Thank you.</a:t>
+              <a:t>In closing, let me restate why we believe this project matters. The primary contribution is not a novel model architecture; it is a complete, deployable, end-to-end pipeline that is purpose-built for the RDTII legal extraction task and that does not currently exist in open-source form.</a:t>
+            </a:r>
+          </a:p>
+          <a:p/>
+          <a:p>
+            <a:r>
+              <a:t>To summarise the four points on screen: first, the system automates approximately eighty percent of the discover-to-describe workflow for Pillars 6 and 7. Second, it is model-agnostic by design, which makes it open-weight capable, fully self-hostable, and released under Apache 2.0. Third, it performs genuine article-level extraction, capturing all six mandatory fields with traceable citations and confidence scores. And fourth, it keeps a human firmly in the loop through a non-technical review interface, while contributing a navigable concept graph that turns isolated provisions into connected knowledge. Thank you very much for your attention; I would be glad to take any questions.</a:t>
             </a:r>
           </a:p>
         </p:txBody>
@@ -651,7 +663,13 @@
           <a:lstStyle/>
           <a:p>
             <a:r>
-              <a:t>[0:15–0:40] The problem we tackle is simple: today the RDTII workflow is almost entirely manual. ESCAP researchers search government portals, retrieve PDFs, read dense legal text, and extract structured fields — article by article, across many jurisdictions and languages. It does not scale, and existing literature targets the EU AI Act and GDPR, not RDTII.</a:t>
+              <a:t>Allow me to begin with the problem we set out to solve. At present, the RDTII workflow is almost entirely manual. ESCAP researchers must search government portals by hand, retrieve regulatory documents, read through dense legal text, and then extract structured data — and they must do this at article-level granularity, not merely at the document level.</a:t>
+            </a:r>
+          </a:p>
+          <a:p/>
+          <a:p>
+            <a:r>
+              <a:t>This work spans numerous Asia-Pacific jurisdictions and several languages, which makes it time-intensive and very difficult to scale. Throughput is bounded by researcher availability and by the languages each researcher can read. Furthermore, any regulatory document that is not already in the ESCAP database is easily overlooked. The figures on the right summarise the burden: the effort is essentially one hundred percent manual, it must cover many jurisdictions and languages, and it demands per-article precision. This is precisely the bottleneck our pipeline is designed to relieve.</a:t>
             </a:r>
           </a:p>
         </p:txBody>
@@ -721,7 +739,13 @@
           <a:lstStyle/>
           <a:p>
             <a:r>
-              <a:t>[0:40–1:00] Our six objectives follow directly. Automate discovery beyond the ESCAP database. Extract all six mandatory fields at article-level. Map every provision to Pillar 6 or 7 sub-indicators with verifiable citations. Ship a self-hostable open tool. Keep every AI component swappable. And provide a human-first review surface.</a:t>
+              <a:t>Our objectives follow directly from that problem. First, we aim to automate document discovery so that the system can locate relevant regulations even when they lie outside the existing ESCAP database. Second, we target genuine article-level extraction, capturing all six mandatory fields — title, last update, URL, scope, provisions, and impact — for every article.</a:t>
+            </a:r>
+          </a:p>
+          <a:p/>
+          <a:p>
+            <a:r>
+              <a:t>Third, every extracted provision must be mapped to the correct Pillar 6 or Pillar 7 sub-indicator, and each mapping must carry a verifiable citation back to the source. Fourth, the tool must be self-hostable and fully open-source, with no dependency on proprietary infrastructure in production. Fifth — and this is central to our design philosophy — every AI component must be model-agnostic and swappable to open-weight models through configuration alone. Finally, we commit to a human-first review experience: a non-technical interface in which any mapping can be verified, edited, or rejected within seconds.</a:t>
             </a:r>
           </a:p>
         </p:txBody>
@@ -791,7 +815,13 @@
           <a:lstStyle/>
           <a:p>
             <a:r>
-              <a:t>[1:00–1:25] To make swappability real, we build on ports and adapters. The core domain depends only on interfaces — never on a concrete model. Every AI component — LLM, OCR, captioner, embeddings, vector store, graph library — is an adapter behind a port, changed via configuration. No vendor lock-in, no production proprietary dependency.</a:t>
+              <a:t>This slide explains the single most important architectural decision in the project: the system is model-agnostic by design. We build on a ports and adapters — also called hexagonal — architecture. The core domain, which contains the business logic of the RDTII workflow, depends only on interfaces, which we call ports. It never references a concrete model directly.</a:t>
+            </a:r>
+          </a:p>
+          <a:p/>
+          <a:p>
+            <a:r>
+              <a:t>Every artificial intelligence component — the large language model, the OCR engine, the captioner, the embedding model, and the graph library — is implemented as an adapter behind one of those ports. As a result, each model is a swappable suggestion rather than a hardcoded commitment. We can run a paid commercial API during development for convenience, and then, for production, resolve every call to an open-weight model such as Llama 3.1 served through Ollama — changing only configuration, with no edits to the domain code. This is not merely an engineering preference: the hackathon rubric explicitly rewards swappability, awarding twenty points in Stage 1 and a further twenty points in Stage 3. The diagram on the right shows the core surrounded by interchangeable adapters.</a:t>
             </a:r>
           </a:p>
         </p:txBody>
@@ -861,7 +891,13 @@
           <a:lstStyle/>
           <a:p>
             <a:r>
-              <a:t>[1:25–2:35] The pipeline runs in five stages. Stages one and two handle automated discovery of legal documents. A crawler — Playwright with anti-bot handling and archive fallback — locates regulations on national portals, gazettes, and ministry sites, recording full provenance per document. Then OCR converts every format to clean text at under five percent character error rate, and a vision-language captioner produces a short descriptor of each section. That caption becomes the basis for every downstream tag, so we are not hostage to OCR noise on scanned or non-English documents. Stage three handles mapping. We tag each section multi-label against indicator labels, then a RAG-based LLM call extracts the six mandatory fields with strict JSON schema and a source citation. Stage four is human verification — a non-technical reviewer console where any mapping is accepted, rejected, or edited in seconds, with a direct link back to the source span.</a:t>
+              <a:t>Here is the pipeline as a whole. It runs in five stages. The first four stages cover the discover-to-describe arc that the hackathon requires, and the fifth stage adds our distinctive contribution.</a:t>
+            </a:r>
+          </a:p>
+          <a:p/>
+          <a:p>
+            <a:r>
+              <a:t>In Stage 1, Discovery and Retrieval, a crawler targets national legislation portals, official gazettes, and ministry websites, recording full provenance for every document. In Stage 2, OCR and Captioning, we convert any document format into clean, machine-readable text at below five percent character error rate; importantly, a SigLIP-style caption is produced for each section and becomes the basis for tagging, so the tags are not held hostage to OCR noise. In Stage 3, Tagging and Extraction, each article is multi-label tagged, and a retrieval-augmented generation step extracts all six mandatory fields together with citations and a confidence score. Stage 4 is the Human Review interface, where a non-technical researcher can accept, reject, or edit any mapping in seconds, with each record linked back to its source. Finally, Stage 5 connects the tagged provisions into a weighted, pruned, navigable concept graph — which I will describe in more detail shortly.</a:t>
             </a:r>
           </a:p>
         </p:txBody>
@@ -931,7 +967,13 @@
           <a:lstStyle/>
           <a:p>
             <a:r>
-              <a:t>[2:35–3:15] Stage five is our core contribution. From the tagged nodes, we derive two artifacts in parallel. The concept graph is subtractive — we start from the complete pairwise graph and drop edges below a calibrated threshold, leaving only topical borders. Then Louvain communities and weighted PageRank score importance within the surviving web. Independently, Formal Concept Analysis on the node-by-tag matrix produces a generality tree: more tags imply fewer matching sections, so depth equals specificity. Together they give us entry-point categories opening into ranked subcategories — navigable cross-jurisdiction evidence.</a:t>
+              <a:t>Stage 5 is what we consider the core architectural contribution of the project, because it goes beyond extraction and turns isolated records into knowledge. After tagging, each article becomes a node. We then draw weighted edges between nodes based on two signals: the overlap of their tags, weighted by inverse document frequency, and the cosine similarity of their embeddings.</a:t>
+            </a:r>
+          </a:p>
+          <a:p/>
+          <a:p>
+            <a:r>
+              <a:t>To keep the graph meaningful and reproducible, we apply pseudo-deterministic threshold pruning: every edge below a calibrated threshold, theta, is removed, and because we fix the random seeds and theta, the same inputs always produce the same graph. We then run community detection using NetworkX and the Louvain method — deliberately chosen because it is BSD-licensed and therefore compatible with our Apache repository. On top of this we apply Formal Concept Analysis to build a generality hierarchy, where provisions with more tags are more specific, and weighted PageRank to rank entry points. The outcome is a navigable map: the reader starts from broad entry-point categories and drills down into ranked, specific sub-topics, with related provisions cross-linked automatically.</a:t>
             </a:r>
           </a:p>
         </p:txBody>
@@ -1001,7 +1043,13 @@
           <a:lstStyle/>
           <a:p>
             <a:r>
-              <a:t>[3:15–3:35] Every model named here is a starting suggestion, not a commitment. Development uses Claude or GPT; production resolves to open-weight Llama 3.1 via Ollama with a single config change. All reused components are Apache-2.0 compatible, audited for license discipline.</a:t>
+              <a:t>This table sets out the technology stack, but the way to read it is important. Each row is a layer that sits behind a port — an interface. The middle column lists the adapter we suggest for development, and the right column lists the open-weight target we resolve to in production. The point is that these are reference suggestions, not hard commitments; any of them can be replaced through configuration.</a:t>
+            </a:r>
+          </a:p>
+          <a:p/>
+          <a:p>
+            <a:r>
+              <a:t>For the language model we may use Claude or GPT in development and Llama 3.1 in production. For captioning we use Qwen2-VL or ColQwen2, both Apache-licensed, with an OCR-text fallback. Embeddings use the multilingual BGE-M3 model. OCR is handled by Tesseract 5 with OpenCV, falling back to PaddleOCR for Southeast Asian scripts. The vector store is pgvector or Chroma, both self-hostable. The graph layer uses NetworkX and an MIT-licensed Formal Concept Analysis library. Backend is FastAPI, frontend is Next.js, and the whole system ships with Docker Compose. Critically, every component is Apache-2.0-compatible, which is a licensing requirement of the competition, and each reused component will be disclosed in the Technical Memo with its licence verified.</a:t>
             </a:r>
           </a:p>
         </p:txBody>
@@ -1071,7 +1119,13 @@
           <a:lstStyle/>
           <a:p>
             <a:r>
-              <a:t>[3:35–3:50] On viability — open-weight self-hosted cost is roughly five to ten cents per fifty-page document, API at ten to twenty-five cents. We are finale-ready for ten countries with no retraining. Everything ships via docker-compose on commodity hardware.</a:t>
+              <a:t>Beyond the design, the project must be credible in practice, so this slide addresses coverage, cost, and sustainability. On coverage, in Round 1 the tool will be evaluated against five to ten documents from three provided countries, including at least one non-English jurisdiction handled by our translation pipeline. The architecture is designed to scale to the ten assigned countries at the finale without any retraining.</a:t>
+            </a:r>
+          </a:p>
+          <a:p/>
+          <a:p>
+            <a:r>
+              <a:t>On cost, the figures are deliberately conservative. In the open-weight configuration, running Llama 3.1 8B locally, the API fee for a fifty-page document is effectively zero; the only cost is cloud GPU compute, approximately five to ten US cents per document at batch rates. If a commercial API is used instead, the cost is roughly ten to twenty-five cents per document. On sustainability, the entire pipeline is self-hostable through Docker on commodity hardware, with no proprietary dependency in production, and its modular design means the OCR engine, the language model, and the vector database can each be upgraded independently over time. Exact benchmarks will be reported in the Technical Memo after empirical testing.</a:t>
             </a:r>
           </a:p>
         </p:txBody>
@@ -1141,7 +1195,13 @@
           <a:lstStyle/>
           <a:p>
             <a:r>
-              <a:t>[3:50–3:55] The path to October runs from the May application through training workshops, Round 1, the hybrid pitch, and the Bangkok finale.</a:t>
+              <a:t>This slide lays out the timeline through to the award ceremony. The immediate milestone is the application submission on the twenty-fifth of May 2026, which comprises our CVs, the concept video, the Technical Memo, and the signed declaration. The shortlist is announced at the end of May, followed by ESCAP and KMITL training workshops in early June.</a:t>
+            </a:r>
+          </a:p>
+          <a:p/>
+          <a:p>
+            <a:r>
+              <a:t>The first major technical checkpoint is the Round 1 submission on the twentieth of July, where the tool is evaluated on three provided countries, followed by the hybrid pitch at the end of that month. The final submission is due on the thirtieth of September, and the award ceremony takes place in Bangkok on the fifteenth of October. Our development plan is sequenced so that a working three-country demonstration is ready well ahead of Round 1, leaving the remaining time for hardening, additional country coverage, and the empirical benchmarking we will report in the memo.</a:t>
             </a:r>
           </a:p>
         </p:txBody>
@@ -4314,7 +4374,7 @@
                 </a:solidFill>
                 <a:latin typeface="Georgia"/>
               </a:rPr>
-              <a:t>RDTII AutoExtract</a:t>
+              <a:t>Zetarix</a:t>
             </a:r>
           </a:p>
           <a:p>
@@ -4323,7 +4383,7 @@
                 <a:spcPts val="0"/>
               </a:spcBef>
               <a:spcAft>
-                <a:spcPts val="0"/>
+                <a:spcPts val="600"/>
               </a:spcAft>
             </a:pPr>
             <a:r>
@@ -4334,6 +4394,25 @@
                 <a:latin typeface="Calibri"/>
               </a:rPr>
               <a:t>An Open-Source, Model-Agnostic AI Pipeline for Automated Digital Trade Regulatory Analysis Across Asia-Pacific Jurisdictions</a:t>
+            </a:r>
+          </a:p>
+          <a:p>
+            <a:pPr algn="l">
+              <a:spcBef>
+                <a:spcPts val="0"/>
+              </a:spcBef>
+              <a:spcAft>
+                <a:spcPts val="0"/>
+              </a:spcAft>
+            </a:pPr>
+            <a:r>
+              <a:rPr sz="1500" b="1" i="0">
+                <a:solidFill>
+                  <a:srgbClr val="9FC4E6"/>
+                </a:solidFill>
+                <a:latin typeface="Calibri"/>
+              </a:rPr>
+              <a:t>RDTII  —  Regional Digital Trade Integration Index (UN ESCAP)</a:t>
             </a:r>
           </a:p>
         </p:txBody>
@@ -4446,6 +4525,14 @@
           </a:bodyPr>
           <a:lstStyle/>
           <a:p>
+            <a:pPr algn="l">
+              <a:spcBef>
+                <a:spcPts val="0"/>
+              </a:spcBef>
+              <a:spcAft>
+                <a:spcPts val="0"/>
+              </a:spcAft>
+            </a:pPr>
             <a:r>
               <a:rPr sz="1300" b="1" i="0">
                 <a:solidFill>
@@ -4453,7 +4540,7 @@
                 </a:solidFill>
                 <a:latin typeface="Calibri"/>
               </a:rPr>
-              <a:t>Team Arkova   ·   Licensed under Apache 2.0</a:t>
+              <a:t>Licensed under Apache 2.0</a:t>
             </a:r>
           </a:p>
         </p:txBody>
@@ -4837,6 +4924,14 @@
           </a:bodyPr>
           <a:lstStyle/>
           <a:p>
+            <a:pPr algn="l">
+              <a:spcBef>
+                <a:spcPts val="0"/>
+              </a:spcBef>
+              <a:spcAft>
+                <a:spcPts val="0"/>
+              </a:spcAft>
+            </a:pPr>
             <a:r>
               <a:rPr sz="1300" b="0" i="0">
                 <a:solidFill>
@@ -4844,7 +4939,7 @@
                 </a:solidFill>
                 <a:latin typeface="Calibri"/>
               </a:rPr>
-              <a:t>Team Arkova   ·   Repository to be published under Apache 2.0   ·   escap-digitaltrade-hackathon@un.org</a:t>
+              <a:t>Thank you.   ·   Repository to be published under Apache 2.0   ·   escap-digitaltrade-hackathon@un.org</a:t>
             </a:r>
           </a:p>
         </p:txBody>
@@ -5120,7 +5215,7 @@
                 </a:solidFill>
                 <a:latin typeface="Calibri"/>
               </a:rPr>
-              <a:t>RDTII AutoExtract  ·  UN ESCAP &amp; KMITL Global Hackathon 2026</a:t>
+              <a:t>Zetarix  ·  UN ESCAP &amp; KMITL Global Hackathon 2026</a:t>
             </a:r>
           </a:p>
         </p:txBody>
@@ -5761,7 +5856,7 @@
                 </a:solidFill>
                 <a:latin typeface="Calibri"/>
               </a:rPr>
-              <a:t>RDTII AutoExtract  ·  UN ESCAP &amp; KMITL Global Hackathon 2026</a:t>
+              <a:t>Zetarix  ·  UN ESCAP &amp; KMITL Global Hackathon 2026</a:t>
             </a:r>
           </a:p>
         </p:txBody>
@@ -7087,7 +7182,7 @@
                 </a:solidFill>
                 <a:latin typeface="Calibri"/>
               </a:rPr>
-              <a:t>RDTII AutoExtract  ·  UN ESCAP &amp; KMITL Global Hackathon 2026</a:t>
+              <a:t>Zetarix  ·  UN ESCAP &amp; KMITL Global Hackathon 2026</a:t>
             </a:r>
           </a:p>
         </p:txBody>
@@ -8030,7 +8125,7 @@
                 </a:solidFill>
                 <a:latin typeface="Calibri"/>
               </a:rPr>
-              <a:t>RDTII AutoExtract  ·  UN ESCAP &amp; KMITL Global Hackathon 2026</a:t>
+              <a:t>Zetarix  ·  UN ESCAP &amp; KMITL Global Hackathon 2026</a:t>
             </a:r>
           </a:p>
         </p:txBody>
@@ -9312,8 +9407,8 @@
         </p:nvCxnSpPr>
         <p:spPr>
           <a:xfrm flipH="1" flipV="1">
-            <a:off x="7962284" y="4457700"/>
-            <a:ext cx="1227436" cy="617220"/>
+            <a:off x="7962284" y="3689604"/>
+            <a:ext cx="1227436" cy="420624"/>
           </a:xfrm>
           <a:prstGeom prst="bentConnector3">
             <a:avLst/>
@@ -9348,8 +9443,8 @@
         </p:nvCxnSpPr>
         <p:spPr>
           <a:xfrm>
-            <a:off x="9189720" y="2606040"/>
-            <a:ext cx="1227435" cy="617220"/>
+            <a:off x="9189720" y="2427732"/>
+            <a:ext cx="1227435" cy="420624"/>
           </a:xfrm>
           <a:prstGeom prst="bentConnector3">
             <a:avLst/>
@@ -9384,8 +9479,8 @@
         </p:nvCxnSpPr>
         <p:spPr>
           <a:xfrm flipH="1" flipV="1">
-            <a:off x="7962284" y="3223260"/>
-            <a:ext cx="1227436" cy="617220"/>
+            <a:off x="7962284" y="2848356"/>
+            <a:ext cx="1227436" cy="420624"/>
           </a:xfrm>
           <a:prstGeom prst="bentConnector3">
             <a:avLst/>
@@ -9420,8 +9515,8 @@
         </p:nvCxnSpPr>
         <p:spPr>
           <a:xfrm flipH="1">
-            <a:off x="7962284" y="3840480"/>
-            <a:ext cx="1227436" cy="617220"/>
+            <a:off x="7962284" y="3268980"/>
+            <a:ext cx="1227436" cy="420624"/>
           </a:xfrm>
           <a:prstGeom prst="bentConnector3">
             <a:avLst/>
@@ -9456,8 +9551,8 @@
         </p:nvCxnSpPr>
         <p:spPr>
           <a:xfrm>
-            <a:off x="9189720" y="3840480"/>
-            <a:ext cx="0" cy="1234440"/>
+            <a:off x="9189720" y="3268980"/>
+            <a:ext cx="0" cy="841248"/>
           </a:xfrm>
           <a:prstGeom prst="bentConnector3">
             <a:avLst/>
@@ -9492,8 +9587,8 @@
         </p:nvCxnSpPr>
         <p:spPr>
           <a:xfrm>
-            <a:off x="9189720" y="3840480"/>
-            <a:ext cx="1227435" cy="617220"/>
+            <a:off x="9189720" y="3268980"/>
+            <a:ext cx="1227435" cy="420624"/>
           </a:xfrm>
           <a:prstGeom prst="bentConnector3">
             <a:avLst/>
@@ -9528,8 +9623,8 @@
         </p:nvCxnSpPr>
         <p:spPr>
           <a:xfrm flipV="1">
-            <a:off x="9189720" y="3223260"/>
-            <a:ext cx="1227435" cy="617220"/>
+            <a:off x="9189720" y="2848356"/>
+            <a:ext cx="1227435" cy="420624"/>
           </a:xfrm>
           <a:prstGeom prst="bentConnector3">
             <a:avLst/>
@@ -9564,8 +9659,8 @@
         </p:nvCxnSpPr>
         <p:spPr>
           <a:xfrm flipV="1">
-            <a:off x="9189720" y="2606040"/>
-            <a:ext cx="0" cy="1234440"/>
+            <a:off x="9189720" y="2427732"/>
+            <a:ext cx="0" cy="841248"/>
           </a:xfrm>
           <a:prstGeom prst="bentConnector3">
             <a:avLst/>
@@ -9801,7 +9896,7 @@
                 </a:solidFill>
                 <a:latin typeface="Calibri"/>
               </a:rPr>
-              <a:t>RDTII AutoExtract  ·  UN ESCAP &amp; KMITL Global Hackathon 2026</a:t>
+              <a:t>Zetarix  ·  UN ESCAP &amp; KMITL Global Hackathon 2026</a:t>
             </a:r>
           </a:p>
         </p:txBody>
@@ -9870,6 +9965,11 @@
           </a:bodyPr>
           <a:lstStyle/>
           <a:p>
+            <a:pPr algn="l">
+              <a:spcAft>
+                <a:spcPts val="1200"/>
+              </a:spcAft>
+            </a:pPr>
             <a:r>
               <a:rPr sz="1500" b="1">
                 <a:solidFill>
@@ -9877,10 +9977,24 @@
                 </a:solidFill>
                 <a:latin typeface="Calibri"/>
               </a:rPr>
-              <a:t>—  One shared seed: tagged nodes from Stage 3. Stage 5 derives two artifacts in parallel.</a:t>
-            </a:r>
-          </a:p>
-          <a:p>
+              <a:t>—  </a:t>
+            </a:r>
+            <a:r>
+              <a:rPr sz="1500" b="0">
+                <a:solidFill>
+                  <a:srgbClr val="334455"/>
+                </a:solidFill>
+                <a:latin typeface="Calibri"/>
+              </a:rPr>
+              <a:t>Edges weight tag overlap (IDF-weighted) and embedding cosine similarity between provisions.</a:t>
+            </a:r>
+          </a:p>
+          <a:p>
+            <a:pPr algn="l">
+              <a:spcAft>
+                <a:spcPts val="1200"/>
+              </a:spcAft>
+            </a:pPr>
             <a:r>
               <a:rPr sz="1500" b="1">
                 <a:solidFill>
@@ -9888,10 +10002,24 @@
                 </a:solidFill>
                 <a:latin typeface="Calibri"/>
               </a:rPr>
-              <a:t>—  Concept graph (subtractive): start from the complete pairwise graph, then drop edges where w = α·IDF-Jaccard(tags) + (1−α)·cosine(emb) falls below a calibrated θ. Louvain communities + weighted PageRank score influence.</a:t>
-            </a:r>
-          </a:p>
-          <a:p>
+              <a:t>—  </a:t>
+            </a:r>
+            <a:r>
+              <a:rPr sz="1500" b="0">
+                <a:solidFill>
+                  <a:srgbClr val="334455"/>
+                </a:solidFill>
+                <a:latin typeface="Calibri"/>
+              </a:rPr>
+              <a:t>Pseudo-deterministic threshold pruning: edges below a calibrated θ are removed; results reproduce given fixed seeds and θ.</a:t>
+            </a:r>
+          </a:p>
+          <a:p>
+            <a:pPr algn="l">
+              <a:spcAft>
+                <a:spcPts val="1200"/>
+              </a:spcAft>
+            </a:pPr>
             <a:r>
               <a:rPr sz="1500" b="1">
                 <a:solidFill>
@@ -9899,18 +10027,66 @@
                 </a:solidFill>
                 <a:latin typeface="Calibri"/>
               </a:rPr>
-              <a:t>—  Generality tree (algebraic): Formal Concept Analysis on the node × tag matrix — independent of graph edges. Intent = tags, extent = sections; more tags ⇒ deeper, more specific. Together: entry-point category → PageRank-ranked subcategories.</a:t>
-            </a:r>
-          </a:p>
-          <a:p>
+              <a:t>—  </a:t>
+            </a:r>
+            <a:r>
+              <a:rPr sz="1500" b="0">
+                <a:solidFill>
+                  <a:srgbClr val="334455"/>
+                </a:solidFill>
+                <a:latin typeface="Calibri"/>
+              </a:rPr>
+              <a:t>Community detection (NetworkX / Louvain — BSD) produces Obsidian-style topical groupings.</a:t>
+            </a:r>
+          </a:p>
+          <a:p>
+            <a:pPr algn="l">
+              <a:spcAft>
+                <a:spcPts val="1200"/>
+              </a:spcAft>
+            </a:pPr>
             <a:r>
               <a:rPr sz="1500" b="1">
                 <a:solidFill>
-                  <a:srgbClr val="1F6FB2"/>
-                </a:solidFill>
-                <a:latin typeface="Calibri"/>
-              </a:rPr>
-              <a:t>—  Pseudo-deterministic: fixed seeds + θ ⇒ reproducible. Every edge stores its basis (shared tags, cosine) — no black-box connections.</a:t>
+                  <a:srgbClr val="2E8B6F"/>
+                </a:solidFill>
+                <a:latin typeface="Calibri"/>
+              </a:rPr>
+              <a:t>—  </a:t>
+            </a:r>
+            <a:r>
+              <a:rPr sz="1500" b="0">
+                <a:solidFill>
+                  <a:srgbClr val="334455"/>
+                </a:solidFill>
+                <a:latin typeface="Calibri"/>
+              </a:rPr>
+              <a:t>Formal Concept Analysis builds a generality hierarchy; weighted PageRank ranks entry points and orders within levels.</a:t>
+            </a:r>
+          </a:p>
+          <a:p>
+            <a:pPr algn="l">
+              <a:spcAft>
+                <a:spcPts val="0"/>
+              </a:spcAft>
+            </a:pPr>
+            <a:r>
+              <a:rPr sz="1500" b="1">
+                <a:solidFill>
+                  <a:srgbClr val="2E8B6F"/>
+                </a:solidFill>
+                <a:latin typeface="Calibri"/>
+              </a:rPr>
+              <a:t>—  </a:t>
+            </a:r>
+            <a:r>
+              <a:rPr sz="1500" b="1">
+                <a:solidFill>
+                  <a:srgbClr val="334455"/>
+                </a:solidFill>
+                <a:latin typeface="Calibri"/>
+              </a:rPr>
+              <a:t>Result: broad entry-point categories → ranked specific sub-topics — a navigable map of related provisions.</a:t>
             </a:r>
           </a:p>
         </p:txBody>
@@ -9924,7 +10100,7 @@
         <p:spPr>
           <a:xfrm>
             <a:off x="6858000" y="1920240"/>
-            <a:ext cx="4663440" cy="3840480"/>
+            <a:ext cx="4663440" cy="2697480"/>
           </a:xfrm>
           <a:prstGeom prst="rect">
             <a:avLst/>
@@ -9967,8 +10143,8 @@
         </p:nvSpPr>
         <p:spPr>
           <a:xfrm>
-            <a:off x="8732520" y="2148840"/>
-            <a:ext cx="914400" cy="914400"/>
+            <a:off x="8787384" y="2025396"/>
+            <a:ext cx="804672" cy="804672"/>
           </a:xfrm>
           <a:prstGeom prst="ellipse">
             <a:avLst/>
@@ -10029,8 +10205,8 @@
         </p:nvSpPr>
         <p:spPr>
           <a:xfrm>
-            <a:off x="9959955" y="2766060"/>
-            <a:ext cx="914400" cy="914400"/>
+            <a:off x="10014819" y="2446020"/>
+            <a:ext cx="804672" cy="804672"/>
           </a:xfrm>
           <a:prstGeom prst="ellipse">
             <a:avLst/>
@@ -10091,8 +10267,8 @@
         </p:nvSpPr>
         <p:spPr>
           <a:xfrm>
-            <a:off x="9959955" y="4000500"/>
-            <a:ext cx="914400" cy="914400"/>
+            <a:off x="10014819" y="3287268"/>
+            <a:ext cx="804672" cy="804672"/>
           </a:xfrm>
           <a:prstGeom prst="ellipse">
             <a:avLst/>
@@ -10153,8 +10329,8 @@
         </p:nvSpPr>
         <p:spPr>
           <a:xfrm>
-            <a:off x="8732520" y="4617720"/>
-            <a:ext cx="914400" cy="914400"/>
+            <a:off x="8787384" y="3707892"/>
+            <a:ext cx="804672" cy="804672"/>
           </a:xfrm>
           <a:prstGeom prst="ellipse">
             <a:avLst/>
@@ -10215,8 +10391,8 @@
         </p:nvSpPr>
         <p:spPr>
           <a:xfrm>
-            <a:off x="7505084" y="4000500"/>
-            <a:ext cx="914400" cy="914400"/>
+            <a:off x="7559948" y="3287268"/>
+            <a:ext cx="804672" cy="804672"/>
           </a:xfrm>
           <a:prstGeom prst="ellipse">
             <a:avLst/>
@@ -10277,8 +10453,8 @@
         </p:nvSpPr>
         <p:spPr>
           <a:xfrm>
-            <a:off x="7505084" y="2766060"/>
-            <a:ext cx="914400" cy="914400"/>
+            <a:off x="7559948" y="2446020"/>
+            <a:ext cx="804672" cy="804672"/>
           </a:xfrm>
           <a:prstGeom prst="ellipse">
             <a:avLst/>
@@ -10339,8 +10515,8 @@
         </p:nvSpPr>
         <p:spPr>
           <a:xfrm>
-            <a:off x="8549640" y="3200400"/>
-            <a:ext cx="1280160" cy="1280160"/>
+            <a:off x="8659368" y="2738628"/>
+            <a:ext cx="1060704" cy="1060704"/>
           </a:xfrm>
           <a:prstGeom prst="ellipse">
             <a:avLst/>
@@ -10393,6 +10569,186 @@
             <a:br/>
             <a:r>
               <a:t>Flows</a:t>
+            </a:r>
+          </a:p>
+        </p:txBody>
+      </p:sp>
+      <p:sp>
+        <p:nvSpPr>
+          <p:cNvPr id="26" name="Rounded Rectangle 25"/>
+          <p:cNvSpPr/>
+          <p:nvPr/>
+        </p:nvSpPr>
+        <p:spPr>
+          <a:xfrm>
+            <a:off x="6858000" y="4800600"/>
+            <a:ext cx="4663440" cy="1554480"/>
+          </a:xfrm>
+          <a:prstGeom prst="roundRect">
+            <a:avLst/>
+          </a:prstGeom>
+          <a:solidFill>
+            <a:srgbClr val="0E2A47"/>
+          </a:solidFill>
+          <a:ln>
+            <a:noFill/>
+          </a:ln>
+          <a:effectLst/>
+        </p:spPr>
+        <p:style>
+          <a:lnRef idx="1">
+            <a:schemeClr val="accent1"/>
+          </a:lnRef>
+          <a:fillRef idx="3">
+            <a:schemeClr val="accent1"/>
+          </a:fillRef>
+          <a:effectRef idx="2">
+            <a:schemeClr val="accent1"/>
+          </a:effectRef>
+          <a:fontRef idx="minor">
+            <a:schemeClr val="lt1"/>
+          </a:fontRef>
+        </p:style>
+        <p:txBody>
+          <a:bodyPr rtlCol="0" anchor="ctr"/>
+          <a:lstStyle/>
+          <a:p>
+            <a:pPr algn="ctr"/>
+          </a:p>
+        </p:txBody>
+      </p:sp>
+      <p:sp>
+        <p:nvSpPr>
+          <p:cNvPr id="27" name="TextBox 26"/>
+          <p:cNvSpPr txBox="1"/>
+          <p:nvPr/>
+        </p:nvSpPr>
+        <p:spPr>
+          <a:xfrm>
+            <a:off x="7086600" y="4910328"/>
+            <a:ext cx="4206240" cy="1335024"/>
+          </a:xfrm>
+          <a:prstGeom prst="rect">
+            <a:avLst/>
+          </a:prstGeom>
+          <a:noFill/>
+        </p:spPr>
+        <p:txBody>
+          <a:bodyPr wrap="square" anchor="t" lIns="0" rIns="0" tIns="0" bIns="0">
+            <a:spAutoFit/>
+          </a:bodyPr>
+          <a:lstStyle/>
+          <a:p>
+            <a:pPr algn="l">
+              <a:spcBef>
+                <a:spcPts val="0"/>
+              </a:spcBef>
+              <a:spcAft>
+                <a:spcPts val="800"/>
+              </a:spcAft>
+            </a:pPr>
+            <a:r>
+              <a:rPr sz="1100" b="1" i="0">
+                <a:solidFill>
+                  <a:srgbClr val="9FC4E6"/>
+                </a:solidFill>
+                <a:latin typeface="Calibri"/>
+              </a:rPr>
+              <a:t>FORMAL MODEL</a:t>
+            </a:r>
+          </a:p>
+          <a:p>
+            <a:pPr>
+              <a:spcAft>
+                <a:spcPts val="300"/>
+              </a:spcAft>
+            </a:pPr>
+            <a:r>
+              <a:rPr sz="1100" b="1">
+                <a:solidFill>
+                  <a:srgbClr val="D7E4F1"/>
+                </a:solidFill>
+                <a:latin typeface="Calibri"/>
+              </a:rPr>
+              <a:t>Edge weight:  </a:t>
+            </a:r>
+            <a:r>
+              <a:rPr sz="1250" b="0">
+                <a:solidFill>
+                  <a:srgbClr val="FFFFFF"/>
+                </a:solidFill>
+                <a:latin typeface="Cambria Math"/>
+              </a:rPr>
+              <a:t>w(i, j) = α · tag(i, j) + β · cos(i, j)</a:t>
+            </a:r>
+          </a:p>
+          <a:p>
+            <a:pPr>
+              <a:spcAft>
+                <a:spcPts val="300"/>
+              </a:spcAft>
+            </a:pPr>
+            <a:r>
+              <a:rPr sz="1100" b="1">
+                <a:solidFill>
+                  <a:srgbClr val="D7E4F1"/>
+                </a:solidFill>
+                <a:latin typeface="Calibri"/>
+              </a:rPr>
+              <a:t>Pruning:  </a:t>
+            </a:r>
+            <a:r>
+              <a:rPr sz="1250" b="0">
+                <a:solidFill>
+                  <a:srgbClr val="FFFFFF"/>
+                </a:solidFill>
+                <a:latin typeface="Cambria Math"/>
+              </a:rPr>
+              <a:t>keep (i, j)  ⟺  w(i, j) ≥ θ</a:t>
+            </a:r>
+          </a:p>
+          <a:p>
+            <a:pPr>
+              <a:spcAft>
+                <a:spcPts val="300"/>
+              </a:spcAft>
+            </a:pPr>
+            <a:r>
+              <a:rPr sz="1100" b="1">
+                <a:solidFill>
+                  <a:srgbClr val="D7E4F1"/>
+                </a:solidFill>
+                <a:latin typeface="Calibri"/>
+              </a:rPr>
+              <a:t>Ranking:  </a:t>
+            </a:r>
+            <a:r>
+              <a:rPr sz="1250" b="0">
+                <a:solidFill>
+                  <a:srgbClr val="FFFFFF"/>
+                </a:solidFill>
+                <a:latin typeface="Cambria Math"/>
+              </a:rPr>
+              <a:t>PR = d · Mᵀ·PR + (1 − d) / N</a:t>
+            </a:r>
+          </a:p>
+          <a:p>
+            <a:pPr algn="l">
+              <a:spcBef>
+                <a:spcPts val="0"/>
+              </a:spcBef>
+              <a:spcAft>
+                <a:spcPts val="0"/>
+              </a:spcAft>
+            </a:pPr>
+            <a:r>
+              <a:rPr sz="900" b="0" i="1">
+                <a:solidFill>
+                  <a:srgbClr val="9FC4E6"/>
+                </a:solidFill>
+                <a:latin typeface="Calibri"/>
+              </a:rPr>
+              <a:t>tag = IDF-weighted tag overlap · cos = embedding cosine similarity · θ = pruning threshold · M = adjacency matrix</a:t>
             </a:r>
           </a:p>
         </p:txBody>
@@ -10668,7 +11024,7 @@
                 </a:solidFill>
                 <a:latin typeface="Calibri"/>
               </a:rPr>
-              <a:t>RDTII AutoExtract  ·  UN ESCAP &amp; KMITL Global Hackathon 2026</a:t>
+              <a:t>Zetarix  ·  UN ESCAP &amp; KMITL Global Hackathon 2026</a:t>
             </a:r>
           </a:p>
         </p:txBody>
@@ -12576,7 +12932,7 @@
                 </a:solidFill>
                 <a:latin typeface="Calibri"/>
               </a:rPr>
-              <a:t>RDTII AutoExtract  ·  UN ESCAP &amp; KMITL Global Hackathon 2026</a:t>
+              <a:t>Zetarix  ·  UN ESCAP &amp; KMITL Global Hackathon 2026</a:t>
             </a:r>
           </a:p>
         </p:txBody>
@@ -13578,7 +13934,7 @@
                 </a:solidFill>
                 <a:latin typeface="Calibri"/>
               </a:rPr>
-              <a:t>RDTII AutoExtract  ·  UN ESCAP &amp; KMITL Global Hackathon 2026</a:t>
+              <a:t>Zetarix  ·  UN ESCAP &amp; KMITL Global Hackathon 2026</a:t>
             </a:r>
           </a:p>
         </p:txBody>

</xml_diff>

<commit_message>
docs: spell out acronyms on first use in deck (RDTII, LLM, OCR, RAG, CER, UI, IDF, FCA, API, GPU)
</commit_message>
<xml_diff>
--- a/docs/RDTII_AutoExtract.pptx
+++ b/docs/RDTII_AutoExtract.pptx
@@ -7322,7 +7322,7 @@
                 </a:solidFill>
                 <a:latin typeface="Calibri"/>
               </a:rPr>
-              <a:t>Every AI model (LLM, OCR, captioner, embeddings, graph) is a swappable suggestion, changed via config — no domain edits.</a:t>
+              <a:t>Every AI model — large language model (LLM), optical character recognition (OCR), captioner, embeddings, graph — is a swappable suggestion, changed via config, no domain edits.</a:t>
             </a:r>
           </a:p>
           <a:p>
@@ -7347,7 +7347,7 @@
                 </a:solidFill>
                 <a:latin typeface="Calibri"/>
               </a:rPr>
-              <a:t>Development can use a paid API; production resolves to open-weight (Llama 3.1 via Ollama) with a single config change.</a:t>
+              <a:t>Development can use a paid application programming interface (API); production resolves to open-weight (Llama 3.1 via Ollama) with a single config change.</a:t>
             </a:r>
           </a:p>
           <a:p>
@@ -8591,7 +8591,7 @@
                 </a:solidFill>
                 <a:latin typeface="Calibri"/>
               </a:rPr>
-              <a:t>Convert any format to clean text at &lt;5% CER; SigLIP-style captions become the basis for tags.</a:t>
+              <a:t>Convert any format to clean text at &lt;5% character error rate (CER); SigLIP-style captions become the basis for tags.</a:t>
             </a:r>
           </a:p>
         </p:txBody>
@@ -8824,7 +8824,7 @@
                 </a:solidFill>
                 <a:latin typeface="Calibri"/>
               </a:rPr>
-              <a:t>Multi-label tag each article; RAG extracts all 6 fields with citations and confidence scores.</a:t>
+              <a:t>Multi-label tag each article; retrieval-augmented generation (RAG) extracts all 6 fields with citations and confidence scores.</a:t>
             </a:r>
           </a:p>
         </p:txBody>
@@ -9057,7 +9057,7 @@
                 </a:solidFill>
                 <a:latin typeface="Calibri"/>
               </a:rPr>
-              <a:t>Non-technical UI: Accept, Reject, or Edit each mapping in seconds, linked to the source.</a:t>
+              <a:t>Non-technical user interface (UI): Accept, Reject, or Edit each mapping in seconds, linked to the source.</a:t>
             </a:r>
           </a:p>
         </p:txBody>
@@ -9986,7 +9986,7 @@
                 </a:solidFill>
                 <a:latin typeface="Calibri"/>
               </a:rPr>
-              <a:t>Edges weight tag overlap (IDF-weighted) and embedding cosine similarity between provisions.</a:t>
+              <a:t>Edges weight tag overlap (inverse document frequency, IDF–weighted) and embedding cosine similarity between provisions.</a:t>
             </a:r>
           </a:p>
           <a:p>
@@ -10061,7 +10061,7 @@
                 </a:solidFill>
                 <a:latin typeface="Calibri"/>
               </a:rPr>
-              <a:t>Formal Concept Analysis builds a generality hierarchy; weighted PageRank ranks entry points and orders within levels.</a:t>
+              <a:t>Formal Concept Analysis (FCA) builds a generality hierarchy; weighted PageRank ranks entry points and orders within levels.</a:t>
             </a:r>
           </a:p>
           <a:p>
@@ -13405,7 +13405,7 @@
                 </a:solidFill>
                 <a:latin typeface="Calibri"/>
               </a:rPr>
-              <a:t>Cloud GPU compute: ≈ USD 0.05–0.10 per document at batch rates.</a:t>
+              <a:t>Cloud graphics processing unit (GPU) compute: ≈ USD 0.05–0.10 per document at batch rates.</a:t>
             </a:r>
           </a:p>
           <a:p>

</xml_diff>